<commit_message>
팀명 = Team Kyber 확정 + 트랙션[15] design-partner 처리(숫자 제거→Ask 연결)
- 팀명 = Team Kyber(제품명과 동일). title 푸터 + Team[16] 헤드라인 A·B 반영.
- design partner 실수치 = 서명 0/활성 대화 1(라이너 비공식·미확정)/발송 3
  (모의 소개는 전부 가상). 0을 부풀리지 않기로 → 슬라이드 카운트 제거하고
  Ask(디자인 파트너 웜인트로 요청)와 연결(0이 Ask 서사와 정합).
- 덱 A·B 재생성(17장·오프캔버스 0·실명 누출 0). 아웃라인·_START_HERE 동기화.
- 🚩 잔여: Team[16] 역할 표기 vs 메모리 불일치(사용자=CEO) 팀 확정.
</commit_message>
<xml_diff>
--- a/deliverables/Pitch_Deck_VersionA_Market-Shift_EN.pptx
+++ b/deliverables/Pitch_Deck_VersionA_Market-Shift_EN.pptx
@@ -4738,7 +4738,7 @@
                 </a:solidFill>
                 <a:latin typeface="Calibri"/>
               </a:rPr>
-              <a:t>Team · 2026 · Presenter</a:t>
+              <a:t>Team Kyber · 2026</a:t>
             </a:r>
           </a:p>
           <a:p>
@@ -9886,7 +9886,7 @@
                 </a:solidFill>
                 <a:latin typeface="Calibri"/>
               </a:rPr>
-              <a:t>▸  Outreach live (Korea AI startups + US Top 5). Design partners: N in progress.</a:t>
+              <a:t>▸  Outreach live (Korea AI startups + US Top 5) — design-partner intros are exactly what we ask for on the final slide.</a:t>
             </a:r>
           </a:p>
           <a:p>
@@ -10076,7 +10076,7 @@
                 </a:solidFill>
                 <a:latin typeface="Calibri"/>
               </a:rPr>
-              <a:t>Technology × customer development — a 2-person core.</a:t>
+              <a:t>Team Kyber — technology × customer development, a 2-person core.</a:t>
             </a:r>
           </a:p>
         </p:txBody>

</xml_diff>

<commit_message>
팀 역할 확정: 김태원=CEO / 유제민=Co-founder + CEO founder-market fit 반영
- 7/27부터의 Team[16] 역할 불일치 종결: 김태원=CEO, 유제민(Malik)=Co-founder·기술 originator.
  (덱이 태원=기술/재민=CEO로 잘못 표기돼 있던 것 정정. §6 quickstart도 정정.)
- CEO 'why us' 채움: 금융×컴공 복수전공(AI 비용=재무 P&L + 에이전트 호출 이해
  = 비용 거버넌스 founder-market fit) + 창업경험 Nemo Scan(북스캔).
  Team[16] 헤드라인 'P&L과 콜스택을 동시에 읽는 창업자'로 재작성, ⚠ 역할 경고 제거.
- 유제민 개인 'why us' 한 줄 = 보류(CEO 지시).
- 덱 A·B 재생성(17장·오프캔버스 0). 아웃라인·_START_HERE 동기화.
</commit_message>
<xml_diff>
--- a/deliverables/Pitch_Deck_VersionA_Market-Shift_EN.pptx
+++ b/deliverables/Pitch_Deck_VersionA_Market-Shift_EN.pptx
@@ -938,7 +938,7 @@
           <a:lstStyle/>
           <a:p>
             <a:r>
-              <a:t>Keep it short. One line on 'why us' to be filled by the team. Resolve the Team-slide role inconsistency before the pitch.</a:t>
+              <a:t>Roles RESOLVED (8/3): Taewon Kim = CEO (finance×CS, prior founder Nemo Scan, customer dev/GTM), Jaemin Yoo (Malik) = Co-founder / technical originator. Lead with founder-market fit — finance+CS is exactly the two lenses cost governance needs. ⚠ Jaemin's personal 'why us' line still TBD (per CEO).</a:t>
             </a:r>
           </a:p>
         </p:txBody>
@@ -10076,7 +10076,7 @@
                 </a:solidFill>
                 <a:latin typeface="Calibri"/>
               </a:rPr>
-              <a:t>Team Kyber — technology × customer development, a 2-person core.</a:t>
+              <a:t>Team Kyber — a founder who reads both the P&amp;L and the call stack.</a:t>
             </a:r>
           </a:p>
         </p:txBody>
@@ -10109,13 +10109,13 @@
               </a:spcAft>
             </a:pPr>
             <a:r>
-              <a:rPr sz="1700" b="0" i="0">
+              <a:rPr sz="1700" b="1" i="0">
                 <a:solidFill>
                   <a:srgbClr val="E8ECF1"/>
                 </a:solidFill>
                 <a:latin typeface="Calibri"/>
               </a:rPr>
-              <a:t>▸  Taewon — technology &amp; product (agent orchestration · infrastructure).</a:t>
+              <a:t>▸  Taewon Kim — CEO. Finance × Computer Science double major → reads AI cost as a financial P&amp;L AND understands the agent call system that generates it = founder-market fit for cost governance.</a:t>
             </a:r>
           </a:p>
           <a:p>
@@ -10127,11 +10127,11 @@
             <a:r>
               <a:rPr sz="1700" b="0" i="0">
                 <a:solidFill>
-                  <a:srgbClr val="E8ECF1"/>
-                </a:solidFill>
-                <a:latin typeface="Calibri"/>
-              </a:rPr>
-              <a:t>▸  Jaemin (Malik) — CEO · customer development · GTM · research.</a:t>
+                  <a:srgbClr val="35C9C9"/>
+                </a:solidFill>
+                <a:latin typeface="Calibri"/>
+              </a:rPr>
+              <a:t>▸  Prior founder — ran 'Nemo Scan', a book-scanning venture, through the full startup cycle. Not a first-timer.</a:t>
             </a:r>
           </a:p>
           <a:p>
@@ -10143,11 +10143,11 @@
             <a:r>
               <a:rPr sz="1700" b="0" i="0">
                 <a:solidFill>
-                  <a:srgbClr val="9AA7B4"/>
-                </a:solidFill>
-                <a:latin typeface="Calibri"/>
-              </a:rPr>
-              <a:t>▸  (Advisors &amp; design-partner relationships added as secured.)</a:t>
+                  <a:srgbClr val="E8ECF1"/>
+                </a:solidFill>
+                <a:latin typeface="Calibri"/>
+              </a:rPr>
+              <a:t>▸  Jaemin Yoo (Malik) — Co-founder · technical originator.</a:t>
             </a:r>
           </a:p>
           <a:p>
@@ -10159,11 +10159,11 @@
             <a:r>
               <a:rPr sz="1700" b="0" i="0">
                 <a:solidFill>
-                  <a:srgbClr val="F2C14E"/>
-                </a:solidFill>
-                <a:latin typeface="Calibri"/>
-              </a:rPr>
-              <a:t>▸  ⚠  Confirm role split — deck vs. memory mismatch on who is CEO; align before the pitch.</a:t>
+                  <a:srgbClr val="9AA7B4"/>
+                </a:solidFill>
+                <a:latin typeface="Calibri"/>
+              </a:rPr>
+              <a:t>▸  (Advisors &amp; design-partner relationships added as secured.)</a:t>
             </a:r>
           </a:p>
         </p:txBody>

</xml_diff>